<commit_message>
docs: update handoff git push status
</commit_message>
<xml_diff>
--- a/健管45成果-王執定.pptx
+++ b/健管45成果-王執定.pptx
@@ -4951,7 +4951,20 @@
                 <a:latin typeface="Microsoft JhengHei" panose="020B0604030504040204" pitchFamily="34" charset="-120"/>
                 <a:ea typeface="Microsoft JhengHei" panose="020B0604030504040204" pitchFamily="34" charset="-120"/>
               </a:rPr>
-              <a:t>味蕾變得更敏感</a:t>
+              <a:t>味蕾變得</a:t>
+            </a:r>
+            <a:r>
+              <a:rPr kumimoji="1" lang="zh-TW" altLang="en-US" sz="2400" b="1">
+                <a:solidFill>
+                  <a:schemeClr val="tx1">
+                    <a:lumMod val="65000"/>
+                    <a:lumOff val="35000"/>
+                  </a:schemeClr>
+                </a:solidFill>
+                <a:latin typeface="Microsoft JhengHei" panose="020B0604030504040204" pitchFamily="34" charset="-120"/>
+                <a:ea typeface="Microsoft JhengHei" panose="020B0604030504040204" pitchFamily="34" charset="-120"/>
+              </a:rPr>
+              <a:t>更敏銳</a:t>
             </a:r>
             <a:endParaRPr kumimoji="1" lang="en-US" altLang="zh-TW" sz="2400" b="1" dirty="0">
               <a:solidFill>

</xml_diff>